<commit_message>
feat: unified portal page, app UI mockups, engineering diagrams, nav consistency
- index.html: hub portal with hero, doc cards, 4-step loop, 3-phase market
- App UI: 4-screen mockup (patient home, training, report, therapist dashboard)
- Engineering diagrams: 4 SVG diagrams (system block, power tree, firmware, control)
- All pages: unified navigation linking back to hub
- Renders: image containers with object-fit to prevent stretching
- PPT: typography switched to Arial for universal compatibility
- Docs README: reorganized with all new files

Co-Authored-By: Claude Opus 4.7 <noreply@anthropic.com>
</commit_message>
<xml_diff>
--- a/docs/Nexum_Pitch_Deck.pptx
+++ b/docs/Nexum_Pitch_Deck.pptx
@@ -3269,7 +3269,7 @@
                 <a:solidFill>
                   <a:srgbClr val="FFFFFF"/>
                 </a:solidFill>
-                <a:latin typeface="Inter"/>
+                <a:latin typeface="Arial"/>
               </a:defRPr>
             </a:pPr>
             <a:r>
@@ -3311,7 +3311,7 @@
                 <a:solidFill>
                   <a:srgbClr val="7DD3FC"/>
                 </a:solidFill>
-                <a:latin typeface="Inter"/>
+                <a:latin typeface="Arial"/>
               </a:defRPr>
             </a:pPr>
             <a:r>
@@ -3396,7 +3396,7 @@
                 <a:solidFill>
                   <a:srgbClr val="94A3B8"/>
                 </a:solidFill>
-                <a:latin typeface="Inter"/>
+                <a:latin typeface="Arial"/>
               </a:defRPr>
             </a:pPr>
             <a:r>
@@ -3438,7 +3438,7 @@
                 <a:solidFill>
                   <a:srgbClr val="64748B"/>
                 </a:solidFill>
-                <a:latin typeface="Inter"/>
+                <a:latin typeface="Arial"/>
               </a:defRPr>
             </a:pPr>
             <a:r>
@@ -3480,7 +3480,7 @@
                 <a:solidFill>
                   <a:srgbClr val="64748B"/>
                 </a:solidFill>
-                <a:latin typeface="Inter"/>
+                <a:latin typeface="Arial"/>
               </a:defRPr>
             </a:pPr>
             <a:r>
@@ -3591,7 +3591,7 @@
                 <a:solidFill>
                   <a:srgbClr val="0096F0"/>
                 </a:solidFill>
-                <a:latin typeface="Inter"/>
+                <a:latin typeface="Arial"/>
               </a:defRPr>
             </a:pPr>
             <a:r>
@@ -3633,7 +3633,7 @@
                 <a:solidFill>
                   <a:srgbClr val="FFFFFF"/>
                 </a:solidFill>
-                <a:latin typeface="Inter"/>
+                <a:latin typeface="Arial"/>
               </a:defRPr>
             </a:pPr>
             <a:r>
@@ -3675,7 +3675,7 @@
                 <a:solidFill>
                   <a:srgbClr val="7DD3FC"/>
                 </a:solidFill>
-                <a:latin typeface="Inter"/>
+                <a:latin typeface="Arial"/>
               </a:defRPr>
             </a:pPr>
             <a:r>
@@ -3848,7 +3848,7 @@
                 <a:solidFill>
                   <a:srgbClr val="FFFFFF"/>
                 </a:solidFill>
-                <a:latin typeface="Inter"/>
+                <a:latin typeface="Arial"/>
               </a:defRPr>
             </a:pPr>
             <a:r>
@@ -3890,7 +3890,7 @@
                 <a:solidFill>
                   <a:srgbClr val="FFFFFF"/>
                 </a:solidFill>
-                <a:latin typeface="Inter"/>
+                <a:latin typeface="Arial"/>
               </a:defRPr>
             </a:pPr>
             <a:r>
@@ -3932,7 +3932,7 @@
                 <a:solidFill>
                   <a:srgbClr val="0096F0"/>
                 </a:solidFill>
-                <a:latin typeface="Inter"/>
+                <a:latin typeface="Arial"/>
               </a:defRPr>
             </a:pPr>
             <a:r>
@@ -3978,7 +3978,7 @@
                 <a:solidFill>
                   <a:srgbClr val="94A3B8"/>
                 </a:solidFill>
-                <a:latin typeface="Inter"/>
+                <a:latin typeface="Arial"/>
               </a:defRPr>
             </a:pPr>
             <a:r>
@@ -4163,7 +4163,7 @@
                 <a:solidFill>
                   <a:srgbClr val="FFFFFF"/>
                 </a:solidFill>
-                <a:latin typeface="Inter"/>
+                <a:latin typeface="Arial"/>
               </a:defRPr>
             </a:pPr>
             <a:r>
@@ -4205,7 +4205,7 @@
                 <a:solidFill>
                   <a:srgbClr val="FFFFFF"/>
                 </a:solidFill>
-                <a:latin typeface="Inter"/>
+                <a:latin typeface="Arial"/>
               </a:defRPr>
             </a:pPr>
             <a:r>
@@ -4247,7 +4247,7 @@
                 <a:solidFill>
                   <a:srgbClr val="0096F0"/>
                 </a:solidFill>
-                <a:latin typeface="Inter"/>
+                <a:latin typeface="Arial"/>
               </a:defRPr>
             </a:pPr>
             <a:r>
@@ -4293,7 +4293,7 @@
                 <a:solidFill>
                   <a:srgbClr val="94A3B8"/>
                 </a:solidFill>
-                <a:latin typeface="Inter"/>
+                <a:latin typeface="Arial"/>
               </a:defRPr>
             </a:pPr>
             <a:r>
@@ -4474,7 +4474,7 @@
                 <a:solidFill>
                   <a:srgbClr val="FFFFFF"/>
                 </a:solidFill>
-                <a:latin typeface="Inter"/>
+                <a:latin typeface="Arial"/>
               </a:defRPr>
             </a:pPr>
             <a:r>
@@ -4516,7 +4516,7 @@
                 <a:solidFill>
                   <a:srgbClr val="94A3B8"/>
                 </a:solidFill>
-                <a:latin typeface="Inter"/>
+                <a:latin typeface="Arial"/>
               </a:defRPr>
             </a:pPr>
             <a:r>
@@ -4558,7 +4558,7 @@
                 <a:solidFill>
                   <a:srgbClr val="64748B"/>
                 </a:solidFill>
-                <a:latin typeface="Inter"/>
+                <a:latin typeface="Arial"/>
               </a:defRPr>
             </a:pPr>
             <a:r>
@@ -4604,7 +4604,7 @@
                 <a:solidFill>
                   <a:srgbClr val="64748B"/>
                 </a:solidFill>
-                <a:latin typeface="Inter"/>
+                <a:latin typeface="Arial"/>
               </a:defRPr>
             </a:pPr>
             <a:r>
@@ -4785,7 +4785,7 @@
                 <a:solidFill>
                   <a:srgbClr val="FFFFFF"/>
                 </a:solidFill>
-                <a:latin typeface="Inter"/>
+                <a:latin typeface="Arial"/>
               </a:defRPr>
             </a:pPr>
             <a:r>
@@ -4827,7 +4827,7 @@
                 <a:solidFill>
                   <a:srgbClr val="94A3B8"/>
                 </a:solidFill>
-                <a:latin typeface="Inter"/>
+                <a:latin typeface="Arial"/>
               </a:defRPr>
             </a:pPr>
             <a:r>
@@ -4869,7 +4869,7 @@
                 <a:solidFill>
                   <a:srgbClr val="64748B"/>
                 </a:solidFill>
-                <a:latin typeface="Inter"/>
+                <a:latin typeface="Arial"/>
               </a:defRPr>
             </a:pPr>
             <a:r>
@@ -4911,7 +4911,7 @@
                 <a:solidFill>
                   <a:srgbClr val="64748B"/>
                 </a:solidFill>
-                <a:latin typeface="Inter"/>
+                <a:latin typeface="Arial"/>
               </a:defRPr>
             </a:pPr>
             <a:r>
@@ -5092,7 +5092,7 @@
                 <a:solidFill>
                   <a:srgbClr val="FFFFFF"/>
                 </a:solidFill>
-                <a:latin typeface="Inter"/>
+                <a:latin typeface="Arial"/>
               </a:defRPr>
             </a:pPr>
             <a:r>
@@ -5134,7 +5134,7 @@
                 <a:solidFill>
                   <a:srgbClr val="94A3B8"/>
                 </a:solidFill>
-                <a:latin typeface="Inter"/>
+                <a:latin typeface="Arial"/>
               </a:defRPr>
             </a:pPr>
             <a:r>
@@ -5176,7 +5176,7 @@
                 <a:solidFill>
                   <a:srgbClr val="64748B"/>
                 </a:solidFill>
-                <a:latin typeface="Inter"/>
+                <a:latin typeface="Arial"/>
               </a:defRPr>
             </a:pPr>
             <a:r>
@@ -5218,7 +5218,7 @@
                 <a:solidFill>
                   <a:srgbClr val="64748B"/>
                 </a:solidFill>
-                <a:latin typeface="Inter"/>
+                <a:latin typeface="Arial"/>
               </a:defRPr>
             </a:pPr>
             <a:r>
@@ -5399,7 +5399,7 @@
                 <a:solidFill>
                   <a:srgbClr val="FFFFFF"/>
                 </a:solidFill>
-                <a:latin typeface="Inter"/>
+                <a:latin typeface="Arial"/>
               </a:defRPr>
             </a:pPr>
             <a:r>
@@ -5441,7 +5441,7 @@
                 <a:solidFill>
                   <a:srgbClr val="94A3B8"/>
                 </a:solidFill>
-                <a:latin typeface="Inter"/>
+                <a:latin typeface="Arial"/>
               </a:defRPr>
             </a:pPr>
             <a:r>
@@ -5483,7 +5483,7 @@
                 <a:solidFill>
                   <a:srgbClr val="64748B"/>
                 </a:solidFill>
-                <a:latin typeface="Inter"/>
+                <a:latin typeface="Arial"/>
               </a:defRPr>
             </a:pPr>
             <a:r>
@@ -5525,7 +5525,7 @@
                 <a:solidFill>
                   <a:srgbClr val="64748B"/>
                 </a:solidFill>
-                <a:latin typeface="Inter"/>
+                <a:latin typeface="Arial"/>
               </a:defRPr>
             </a:pPr>
             <a:r>
@@ -5575,7 +5575,7 @@
                 <a:solidFill>
                   <a:srgbClr val="7DD3FC"/>
                 </a:solidFill>
-                <a:latin typeface="Inter"/>
+                <a:latin typeface="Arial"/>
               </a:defRPr>
             </a:pPr>
             <a:r>
@@ -5617,7 +5617,7 @@
                 <a:solidFill>
                   <a:srgbClr val="94A3B8"/>
                 </a:solidFill>
-                <a:latin typeface="Inter"/>
+                <a:latin typeface="Arial"/>
               </a:defRPr>
             </a:pPr>
             <a:r>
@@ -5659,7 +5659,7 @@
                 <a:solidFill>
                   <a:srgbClr val="94A3B8"/>
                 </a:solidFill>
-                <a:latin typeface="Inter"/>
+                <a:latin typeface="Arial"/>
               </a:defRPr>
             </a:pPr>
             <a:r>
@@ -5762,7 +5762,7 @@
                 <a:solidFill>
                   <a:srgbClr val="64748B"/>
                 </a:solidFill>
-                <a:latin typeface="Inter"/>
+                <a:latin typeface="Arial"/>
               </a:defRPr>
             </a:pPr>
             <a:r>
@@ -5804,7 +5804,7 @@
                 <a:solidFill>
                   <a:srgbClr val="151D2E"/>
                 </a:solidFill>
-                <a:latin typeface="Inter"/>
+                <a:latin typeface="Arial"/>
               </a:defRPr>
             </a:pPr>
             <a:r>
@@ -5977,7 +5977,7 @@
                 <a:solidFill>
                   <a:srgbClr val="0096F0"/>
                 </a:solidFill>
-                <a:latin typeface="Inter"/>
+                <a:latin typeface="Arial"/>
               </a:defRPr>
             </a:pPr>
             <a:r>
@@ -6019,7 +6019,7 @@
                 <a:solidFill>
                   <a:srgbClr val="94A3B8"/>
                 </a:solidFill>
-                <a:latin typeface="Inter"/>
+                <a:latin typeface="Arial"/>
               </a:defRPr>
             </a:pPr>
             <a:r>
@@ -6061,7 +6061,7 @@
                 <a:solidFill>
                   <a:srgbClr val="151D2E"/>
                 </a:solidFill>
-                <a:latin typeface="Inter"/>
+                <a:latin typeface="Arial"/>
               </a:defRPr>
             </a:pPr>
             <a:r>
@@ -6146,7 +6146,7 @@
                 <a:solidFill>
                   <a:srgbClr val="0096F0"/>
                 </a:solidFill>
-                <a:latin typeface="Inter"/>
+                <a:latin typeface="Arial"/>
               </a:defRPr>
             </a:pPr>
             <a:r>
@@ -6188,7 +6188,7 @@
                 <a:solidFill>
                   <a:srgbClr val="64748B"/>
                 </a:solidFill>
-                <a:latin typeface="Inter"/>
+                <a:latin typeface="Arial"/>
               </a:defRPr>
             </a:pPr>
             <a:r>
@@ -6234,7 +6234,7 @@
                 <a:solidFill>
                   <a:srgbClr val="0096F0"/>
                 </a:solidFill>
-                <a:latin typeface="Inter"/>
+                <a:latin typeface="Arial"/>
               </a:defRPr>
             </a:pPr>
             <a:r>
@@ -6319,7 +6319,7 @@
                 <a:solidFill>
                   <a:srgbClr val="94A3B8"/>
                 </a:solidFill>
-                <a:latin typeface="Inter"/>
+                <a:latin typeface="Arial"/>
               </a:defRPr>
             </a:pPr>
             <a:r>
@@ -6449,7 +6449,7 @@
                 <a:solidFill>
                   <a:srgbClr val="0096F0"/>
                 </a:solidFill>
-                <a:latin typeface="Inter"/>
+                <a:latin typeface="Arial"/>
               </a:defRPr>
             </a:pPr>
             <a:r>
@@ -6491,7 +6491,7 @@
                 <a:solidFill>
                   <a:srgbClr val="94A3B8"/>
                 </a:solidFill>
-                <a:latin typeface="Inter"/>
+                <a:latin typeface="Arial"/>
               </a:defRPr>
             </a:pPr>
             <a:r>
@@ -6533,7 +6533,7 @@
                 <a:solidFill>
                   <a:srgbClr val="151D2E"/>
                 </a:solidFill>
-                <a:latin typeface="Inter"/>
+                <a:latin typeface="Arial"/>
               </a:defRPr>
             </a:pPr>
             <a:r>
@@ -6618,7 +6618,7 @@
                 <a:solidFill>
                   <a:srgbClr val="0096F0"/>
                 </a:solidFill>
-                <a:latin typeface="Inter"/>
+                <a:latin typeface="Arial"/>
               </a:defRPr>
             </a:pPr>
             <a:r>
@@ -6660,7 +6660,7 @@
                 <a:solidFill>
                   <a:srgbClr val="64748B"/>
                 </a:solidFill>
-                <a:latin typeface="Inter"/>
+                <a:latin typeface="Arial"/>
               </a:defRPr>
             </a:pPr>
             <a:r>
@@ -6710,7 +6710,7 @@
                 <a:solidFill>
                   <a:srgbClr val="0096F0"/>
                 </a:solidFill>
-                <a:latin typeface="Inter"/>
+                <a:latin typeface="Arial"/>
               </a:defRPr>
             </a:pPr>
             <a:r>
@@ -6795,7 +6795,7 @@
                 <a:solidFill>
                   <a:srgbClr val="94A3B8"/>
                 </a:solidFill>
-                <a:latin typeface="Inter"/>
+                <a:latin typeface="Arial"/>
               </a:defRPr>
             </a:pPr>
             <a:r>
@@ -6925,7 +6925,7 @@
                 <a:solidFill>
                   <a:srgbClr val="0096F0"/>
                 </a:solidFill>
-                <a:latin typeface="Inter"/>
+                <a:latin typeface="Arial"/>
               </a:defRPr>
             </a:pPr>
             <a:r>
@@ -6967,7 +6967,7 @@
                 <a:solidFill>
                   <a:srgbClr val="94A3B8"/>
                 </a:solidFill>
-                <a:latin typeface="Inter"/>
+                <a:latin typeface="Arial"/>
               </a:defRPr>
             </a:pPr>
             <a:r>
@@ -7009,7 +7009,7 @@
                 <a:solidFill>
                   <a:srgbClr val="151D2E"/>
                 </a:solidFill>
-                <a:latin typeface="Inter"/>
+                <a:latin typeface="Arial"/>
               </a:defRPr>
             </a:pPr>
             <a:r>
@@ -7094,7 +7094,7 @@
                 <a:solidFill>
                   <a:srgbClr val="0096F0"/>
                 </a:solidFill>
-                <a:latin typeface="Inter"/>
+                <a:latin typeface="Arial"/>
               </a:defRPr>
             </a:pPr>
             <a:r>
@@ -7136,7 +7136,7 @@
                 <a:solidFill>
                   <a:srgbClr val="64748B"/>
                 </a:solidFill>
-                <a:latin typeface="Inter"/>
+                <a:latin typeface="Arial"/>
               </a:defRPr>
             </a:pPr>
             <a:r>
@@ -7182,7 +7182,7 @@
                 <a:solidFill>
                   <a:srgbClr val="0096F0"/>
                 </a:solidFill>
-                <a:latin typeface="Inter"/>
+                <a:latin typeface="Arial"/>
               </a:defRPr>
             </a:pPr>
             <a:r>
@@ -7267,7 +7267,7 @@
                 <a:solidFill>
                   <a:srgbClr val="94A3B8"/>
                 </a:solidFill>
-                <a:latin typeface="Inter"/>
+                <a:latin typeface="Arial"/>
               </a:defRPr>
             </a:pPr>
             <a:r>
@@ -7397,7 +7397,7 @@
                 <a:solidFill>
                   <a:srgbClr val="0096F0"/>
                 </a:solidFill>
-                <a:latin typeface="Inter"/>
+                <a:latin typeface="Arial"/>
               </a:defRPr>
             </a:pPr>
             <a:r>
@@ -7439,7 +7439,7 @@
                 <a:solidFill>
                   <a:srgbClr val="94A3B8"/>
                 </a:solidFill>
-                <a:latin typeface="Inter"/>
+                <a:latin typeface="Arial"/>
               </a:defRPr>
             </a:pPr>
             <a:r>
@@ -7481,7 +7481,7 @@
                 <a:solidFill>
                   <a:srgbClr val="151D2E"/>
                 </a:solidFill>
-                <a:latin typeface="Inter"/>
+                <a:latin typeface="Arial"/>
               </a:defRPr>
             </a:pPr>
             <a:r>
@@ -7566,7 +7566,7 @@
                 <a:solidFill>
                   <a:srgbClr val="0096F0"/>
                 </a:solidFill>
-                <a:latin typeface="Inter"/>
+                <a:latin typeface="Arial"/>
               </a:defRPr>
             </a:pPr>
             <a:r>
@@ -7608,7 +7608,7 @@
                 <a:solidFill>
                   <a:srgbClr val="64748B"/>
                 </a:solidFill>
-                <a:latin typeface="Inter"/>
+                <a:latin typeface="Arial"/>
               </a:defRPr>
             </a:pPr>
             <a:r>
@@ -7654,7 +7654,7 @@
                 <a:solidFill>
                   <a:srgbClr val="0096F0"/>
                 </a:solidFill>
-                <a:latin typeface="Inter"/>
+                <a:latin typeface="Arial"/>
               </a:defRPr>
             </a:pPr>
             <a:r>
@@ -7739,7 +7739,7 @@
                 <a:solidFill>
                   <a:srgbClr val="7DD3FC"/>
                 </a:solidFill>
-                <a:latin typeface="Inter"/>
+                <a:latin typeface="Arial"/>
               </a:defRPr>
             </a:pPr>
             <a:r>
@@ -7781,7 +7781,7 @@
                 <a:solidFill>
                   <a:srgbClr val="0096F0"/>
                 </a:solidFill>
-                <a:latin typeface="Inter"/>
+                <a:latin typeface="Arial"/>
               </a:defRPr>
             </a:pPr>
             <a:r>
@@ -7935,7 +7935,7 @@
                 <a:solidFill>
                   <a:srgbClr val="FFFFFF"/>
                 </a:solidFill>
-                <a:latin typeface="Inter"/>
+                <a:latin typeface="Arial"/>
               </a:defRPr>
             </a:pPr>
             <a:r>
@@ -8028,7 +8028,7 @@
                 <a:solidFill>
                   <a:srgbClr val="0096F0"/>
                 </a:solidFill>
-                <a:latin typeface="Inter"/>
+                <a:latin typeface="Arial"/>
               </a:defRPr>
             </a:pPr>
             <a:r>
@@ -8070,7 +8070,7 @@
                 <a:solidFill>
                   <a:srgbClr val="FFFFFF"/>
                 </a:solidFill>
-                <a:latin typeface="Inter"/>
+                <a:latin typeface="Arial"/>
               </a:defRPr>
             </a:pPr>
             <a:r>
@@ -8112,7 +8112,7 @@
                 <a:solidFill>
                   <a:srgbClr val="94A3B8"/>
                 </a:solidFill>
-                <a:latin typeface="Inter"/>
+                <a:latin typeface="Arial"/>
               </a:defRPr>
             </a:pPr>
             <a:r>
@@ -8162,7 +8162,7 @@
                 <a:solidFill>
                   <a:srgbClr val="0096F0"/>
                 </a:solidFill>
-                <a:latin typeface="Inter"/>
+                <a:latin typeface="Arial"/>
               </a:defRPr>
             </a:pPr>
             <a:r>
@@ -8204,7 +8204,7 @@
                 <a:solidFill>
                   <a:srgbClr val="FFFFFF"/>
                 </a:solidFill>
-                <a:latin typeface="Inter"/>
+                <a:latin typeface="Arial"/>
               </a:defRPr>
             </a:pPr>
             <a:r>
@@ -8246,7 +8246,7 @@
                 <a:solidFill>
                   <a:srgbClr val="94A3B8"/>
                 </a:solidFill>
-                <a:latin typeface="Inter"/>
+                <a:latin typeface="Arial"/>
               </a:defRPr>
             </a:pPr>
             <a:r>
@@ -8296,7 +8296,7 @@
                 <a:solidFill>
                   <a:srgbClr val="0096F0"/>
                 </a:solidFill>
-                <a:latin typeface="Inter"/>
+                <a:latin typeface="Arial"/>
               </a:defRPr>
             </a:pPr>
             <a:r>
@@ -8338,7 +8338,7 @@
                 <a:solidFill>
                   <a:srgbClr val="FFFFFF"/>
                 </a:solidFill>
-                <a:latin typeface="Inter"/>
+                <a:latin typeface="Arial"/>
               </a:defRPr>
             </a:pPr>
             <a:r>
@@ -8380,7 +8380,7 @@
                 <a:solidFill>
                   <a:srgbClr val="94A3B8"/>
                 </a:solidFill>
-                <a:latin typeface="Inter"/>
+                <a:latin typeface="Arial"/>
               </a:defRPr>
             </a:pPr>
             <a:r>
@@ -8473,7 +8473,7 @@
                 <a:solidFill>
                   <a:srgbClr val="FFFFFF"/>
                 </a:solidFill>
-                <a:latin typeface="Inter"/>
+                <a:latin typeface="Arial"/>
               </a:defRPr>
             </a:pPr>
             <a:r>
@@ -8515,7 +8515,7 @@
                 <a:solidFill>
                   <a:srgbClr val="7DD3FC"/>
                 </a:solidFill>
-                <a:latin typeface="Inter"/>
+                <a:latin typeface="Arial"/>
               </a:defRPr>
             </a:pPr>
             <a:r>
@@ -8669,7 +8669,7 @@
                 <a:solidFill>
                   <a:srgbClr val="0096F0"/>
                 </a:solidFill>
-                <a:latin typeface="Inter"/>
+                <a:latin typeface="Arial"/>
               </a:defRPr>
             </a:pPr>
             <a:r>
@@ -8711,7 +8711,7 @@
                 <a:solidFill>
                   <a:srgbClr val="FFFFFF"/>
                 </a:solidFill>
-                <a:latin typeface="Inter"/>
+                <a:latin typeface="Arial"/>
               </a:defRPr>
             </a:pPr>
             <a:r>
@@ -8796,7 +8796,7 @@
                 <a:solidFill>
                   <a:srgbClr val="FFFFFF"/>
                 </a:solidFill>
-                <a:latin typeface="Inter"/>
+                <a:latin typeface="Arial"/>
               </a:defRPr>
             </a:pPr>
             <a:r>
@@ -8815,7 +8815,7 @@
                 <a:solidFill>
                   <a:srgbClr val="94A3B8"/>
                 </a:solidFill>
-                <a:latin typeface="Inter"/>
+                <a:latin typeface="Arial"/>
               </a:defRPr>
             </a:pPr>
             <a:r>
@@ -8834,7 +8834,7 @@
                 <a:solidFill>
                   <a:srgbClr val="0096F0"/>
                 </a:solidFill>
-                <a:latin typeface="Inter"/>
+                <a:latin typeface="Arial"/>
               </a:defRPr>
             </a:pPr>
             <a:r>
@@ -8853,7 +8853,7 @@
                 <a:solidFill>
                   <a:srgbClr val="94A3B8"/>
                 </a:solidFill>
-                <a:latin typeface="Inter"/>
+                <a:latin typeface="Arial"/>
               </a:defRPr>
             </a:pPr>
             <a:r>
@@ -8872,7 +8872,7 @@
                 <a:solidFill>
                   <a:srgbClr val="94A3B8"/>
                 </a:solidFill>
-                <a:latin typeface="Inter"/>
+                <a:latin typeface="Arial"/>
               </a:defRPr>
             </a:pPr>
             <a:r>
@@ -8891,7 +8891,7 @@
                 <a:solidFill>
                   <a:srgbClr val="94A3B8"/>
                 </a:solidFill>
-                <a:latin typeface="Inter"/>
+                <a:latin typeface="Arial"/>
               </a:defRPr>
             </a:pPr>
             <a:r>
@@ -8910,7 +8910,7 @@
                 <a:solidFill>
                   <a:srgbClr val="94A3B8"/>
                 </a:solidFill>
-                <a:latin typeface="Inter"/>
+                <a:latin typeface="Arial"/>
               </a:defRPr>
             </a:pPr>
             <a:r>
@@ -8929,7 +8929,7 @@
                 <a:solidFill>
                   <a:srgbClr val="0096F0"/>
                 </a:solidFill>
-                <a:latin typeface="Inter"/>
+                <a:latin typeface="Arial"/>
               </a:defRPr>
             </a:pPr>
             <a:r>
@@ -9059,7 +9059,7 @@
                 <a:solidFill>
                   <a:srgbClr val="0096F0"/>
                 </a:solidFill>
-                <a:latin typeface="Inter"/>
+                <a:latin typeface="Arial"/>
               </a:defRPr>
             </a:pPr>
             <a:r>
@@ -9101,7 +9101,7 @@
                 <a:solidFill>
                   <a:srgbClr val="FFFFFF"/>
                 </a:solidFill>
-                <a:latin typeface="Inter"/>
+                <a:latin typeface="Arial"/>
               </a:defRPr>
             </a:pPr>
             <a:r>
@@ -9143,7 +9143,7 @@
                 <a:solidFill>
                   <a:srgbClr val="64748B"/>
                 </a:solidFill>
-                <a:latin typeface="Inter"/>
+                <a:latin typeface="Arial"/>
               </a:defRPr>
             </a:pPr>
             <a:r>
@@ -9273,7 +9273,7 @@
                 <a:solidFill>
                   <a:srgbClr val="0096F0"/>
                 </a:solidFill>
-                <a:latin typeface="Inter"/>
+                <a:latin typeface="Arial"/>
               </a:defRPr>
             </a:pPr>
             <a:r>
@@ -9315,7 +9315,7 @@
                 <a:solidFill>
                   <a:srgbClr val="FFFFFF"/>
                 </a:solidFill>
-                <a:latin typeface="Inter"/>
+                <a:latin typeface="Arial"/>
               </a:defRPr>
             </a:pPr>
             <a:r>
@@ -9357,7 +9357,7 @@
                 <a:solidFill>
                   <a:srgbClr val="64748B"/>
                 </a:solidFill>
-                <a:latin typeface="Inter"/>
+                <a:latin typeface="Arial"/>
               </a:defRPr>
             </a:pPr>
             <a:r>
@@ -9487,7 +9487,7 @@
                 <a:solidFill>
                   <a:srgbClr val="0096F0"/>
                 </a:solidFill>
-                <a:latin typeface="Inter"/>
+                <a:latin typeface="Arial"/>
               </a:defRPr>
             </a:pPr>
             <a:r>
@@ -9529,7 +9529,7 @@
                 <a:solidFill>
                   <a:srgbClr val="FFFFFF"/>
                 </a:solidFill>
-                <a:latin typeface="Inter"/>
+                <a:latin typeface="Arial"/>
               </a:defRPr>
             </a:pPr>
             <a:r>
@@ -9571,7 +9571,7 @@
                 <a:solidFill>
                   <a:srgbClr val="64748B"/>
                 </a:solidFill>
-                <a:latin typeface="Inter"/>
+                <a:latin typeface="Arial"/>
               </a:defRPr>
             </a:pPr>
             <a:r>
@@ -9725,7 +9725,7 @@
                 <a:solidFill>
                   <a:srgbClr val="0096F0"/>
                 </a:solidFill>
-                <a:latin typeface="Inter"/>
+                <a:latin typeface="Arial"/>
               </a:defRPr>
             </a:pPr>
             <a:r>
@@ -9767,7 +9767,7 @@
                 <a:solidFill>
                   <a:srgbClr val="FFFFFF"/>
                 </a:solidFill>
-                <a:latin typeface="Inter"/>
+                <a:latin typeface="Arial"/>
               </a:defRPr>
             </a:pPr>
             <a:r>
@@ -9809,7 +9809,7 @@
                 <a:solidFill>
                   <a:srgbClr val="7DD3FC"/>
                 </a:solidFill>
-                <a:latin typeface="Inter"/>
+                <a:latin typeface="Arial"/>
               </a:defRPr>
             </a:pPr>
             <a:r>
@@ -9982,7 +9982,7 @@
                 <a:solidFill>
                   <a:srgbClr val="FFFFFF"/>
                 </a:solidFill>
-                <a:latin typeface="Inter"/>
+                <a:latin typeface="Arial"/>
               </a:defRPr>
             </a:pPr>
             <a:r>
@@ -10024,7 +10024,7 @@
                 <a:solidFill>
                   <a:srgbClr val="FFFFFF"/>
                 </a:solidFill>
-                <a:latin typeface="Inter"/>
+                <a:latin typeface="Arial"/>
               </a:defRPr>
             </a:pPr>
             <a:r>
@@ -10066,7 +10066,7 @@
                 <a:solidFill>
                   <a:srgbClr val="94A3B8"/>
                 </a:solidFill>
-                <a:latin typeface="Inter"/>
+                <a:latin typeface="Arial"/>
               </a:defRPr>
             </a:pPr>
             <a:r>
@@ -10085,7 +10085,7 @@
                 <a:solidFill>
                   <a:srgbClr val="94A3B8"/>
                 </a:solidFill>
-                <a:latin typeface="Inter"/>
+                <a:latin typeface="Arial"/>
               </a:defRPr>
             </a:pPr>
             <a:r>
@@ -10104,7 +10104,7 @@
                 <a:solidFill>
                   <a:srgbClr val="94A3B8"/>
                 </a:solidFill>
-                <a:latin typeface="Inter"/>
+                <a:latin typeface="Arial"/>
               </a:defRPr>
             </a:pPr>
             <a:r>
@@ -10123,7 +10123,7 @@
                 <a:solidFill>
                   <a:srgbClr val="94A3B8"/>
                 </a:solidFill>
-                <a:latin typeface="Inter"/>
+                <a:latin typeface="Arial"/>
               </a:defRPr>
             </a:pPr>
             <a:r>
@@ -10296,7 +10296,7 @@
                 <a:solidFill>
                   <a:srgbClr val="FFFFFF"/>
                 </a:solidFill>
-                <a:latin typeface="Inter"/>
+                <a:latin typeface="Arial"/>
               </a:defRPr>
             </a:pPr>
             <a:r>
@@ -10338,7 +10338,7 @@
                 <a:solidFill>
                   <a:srgbClr val="FFFFFF"/>
                 </a:solidFill>
-                <a:latin typeface="Inter"/>
+                <a:latin typeface="Arial"/>
               </a:defRPr>
             </a:pPr>
             <a:r>
@@ -10380,7 +10380,7 @@
                 <a:solidFill>
                   <a:srgbClr val="94A3B8"/>
                 </a:solidFill>
-                <a:latin typeface="Inter"/>
+                <a:latin typeface="Arial"/>
               </a:defRPr>
             </a:pPr>
             <a:r>
@@ -10399,7 +10399,7 @@
                 <a:solidFill>
                   <a:srgbClr val="94A3B8"/>
                 </a:solidFill>
-                <a:latin typeface="Inter"/>
+                <a:latin typeface="Arial"/>
               </a:defRPr>
             </a:pPr>
             <a:r>
@@ -10418,7 +10418,7 @@
                 <a:solidFill>
                   <a:srgbClr val="94A3B8"/>
                 </a:solidFill>
-                <a:latin typeface="Inter"/>
+                <a:latin typeface="Arial"/>
               </a:defRPr>
             </a:pPr>
             <a:r>
@@ -10437,7 +10437,7 @@
                 <a:solidFill>
                   <a:srgbClr val="94A3B8"/>
                 </a:solidFill>
-                <a:latin typeface="Inter"/>
+                <a:latin typeface="Arial"/>
               </a:defRPr>
             </a:pPr>
             <a:r>
@@ -10610,7 +10610,7 @@
                 <a:solidFill>
                   <a:srgbClr val="FFFFFF"/>
                 </a:solidFill>
-                <a:latin typeface="Inter"/>
+                <a:latin typeface="Arial"/>
               </a:defRPr>
             </a:pPr>
             <a:r>
@@ -10652,7 +10652,7 @@
                 <a:solidFill>
                   <a:srgbClr val="FFFFFF"/>
                 </a:solidFill>
-                <a:latin typeface="Inter"/>
+                <a:latin typeface="Arial"/>
               </a:defRPr>
             </a:pPr>
             <a:r>
@@ -10694,7 +10694,7 @@
                 <a:solidFill>
                   <a:srgbClr val="94A3B8"/>
                 </a:solidFill>
-                <a:latin typeface="Inter"/>
+                <a:latin typeface="Arial"/>
               </a:defRPr>
             </a:pPr>
             <a:r>
@@ -10713,7 +10713,7 @@
                 <a:solidFill>
                   <a:srgbClr val="94A3B8"/>
                 </a:solidFill>
-                <a:latin typeface="Inter"/>
+                <a:latin typeface="Arial"/>
               </a:defRPr>
             </a:pPr>
             <a:r>
@@ -10732,7 +10732,7 @@
                 <a:solidFill>
                   <a:srgbClr val="94A3B8"/>
                 </a:solidFill>
-                <a:latin typeface="Inter"/>
+                <a:latin typeface="Arial"/>
               </a:defRPr>
             </a:pPr>
             <a:r>
@@ -10751,7 +10751,7 @@
                 <a:solidFill>
                   <a:srgbClr val="94A3B8"/>
                 </a:solidFill>
-                <a:latin typeface="Inter"/>
+                <a:latin typeface="Arial"/>
               </a:defRPr>
             </a:pPr>
             <a:r>
@@ -10924,7 +10924,7 @@
                 <a:solidFill>
                   <a:srgbClr val="FFFFFF"/>
                 </a:solidFill>
-                <a:latin typeface="Inter"/>
+                <a:latin typeface="Arial"/>
               </a:defRPr>
             </a:pPr>
             <a:r>
@@ -10966,7 +10966,7 @@
                 <a:solidFill>
                   <a:srgbClr val="FFFFFF"/>
                 </a:solidFill>
-                <a:latin typeface="Inter"/>
+                <a:latin typeface="Arial"/>
               </a:defRPr>
             </a:pPr>
             <a:r>
@@ -11008,7 +11008,7 @@
                 <a:solidFill>
                   <a:srgbClr val="94A3B8"/>
                 </a:solidFill>
-                <a:latin typeface="Inter"/>
+                <a:latin typeface="Arial"/>
               </a:defRPr>
             </a:pPr>
             <a:r>
@@ -11027,7 +11027,7 @@
                 <a:solidFill>
                   <a:srgbClr val="94A3B8"/>
                 </a:solidFill>
-                <a:latin typeface="Inter"/>
+                <a:latin typeface="Arial"/>
               </a:defRPr>
             </a:pPr>
             <a:r>
@@ -11046,7 +11046,7 @@
                 <a:solidFill>
                   <a:srgbClr val="94A3B8"/>
                 </a:solidFill>
-                <a:latin typeface="Inter"/>
+                <a:latin typeface="Arial"/>
               </a:defRPr>
             </a:pPr>
             <a:r>
@@ -11065,7 +11065,7 @@
                 <a:solidFill>
                   <a:srgbClr val="94A3B8"/>
                 </a:solidFill>
-                <a:latin typeface="Inter"/>
+                <a:latin typeface="Arial"/>
               </a:defRPr>
             </a:pPr>
             <a:r>
@@ -11107,7 +11107,7 @@
                 <a:solidFill>
                   <a:srgbClr val="7DD3FC"/>
                 </a:solidFill>
-                <a:latin typeface="Inter"/>
+                <a:latin typeface="Arial"/>
               </a:defRPr>
             </a:pPr>
             <a:r>
@@ -11210,7 +11210,7 @@
                 <a:solidFill>
                   <a:srgbClr val="64748B"/>
                 </a:solidFill>
-                <a:latin typeface="Inter"/>
+                <a:latin typeface="Arial"/>
               </a:defRPr>
             </a:pPr>
             <a:r>
@@ -11252,7 +11252,7 @@
                 <a:solidFill>
                   <a:srgbClr val="151D2E"/>
                 </a:solidFill>
-                <a:latin typeface="Inter"/>
+                <a:latin typeface="Arial"/>
               </a:defRPr>
             </a:pPr>
             <a:r>
@@ -11425,7 +11425,7 @@
                 <a:solidFill>
                   <a:srgbClr val="94A3B8"/>
                 </a:solidFill>
-                <a:latin typeface="Inter"/>
+                <a:latin typeface="Arial"/>
               </a:defRPr>
             </a:pPr>
             <a:r>
@@ -11467,7 +11467,7 @@
                 <a:solidFill>
                   <a:srgbClr val="151D2E"/>
                 </a:solidFill>
-                <a:latin typeface="Inter"/>
+                <a:latin typeface="Arial"/>
               </a:defRPr>
             </a:pPr>
             <a:r>
@@ -11556,7 +11556,7 @@
                 <a:solidFill>
                   <a:srgbClr val="64748B"/>
                 </a:solidFill>
-                <a:latin typeface="Inter"/>
+                <a:latin typeface="Arial"/>
               </a:defRPr>
             </a:pPr>
             <a:r>
@@ -11686,7 +11686,7 @@
                 <a:solidFill>
                   <a:srgbClr val="94A3B8"/>
                 </a:solidFill>
-                <a:latin typeface="Inter"/>
+                <a:latin typeface="Arial"/>
               </a:defRPr>
             </a:pPr>
             <a:r>
@@ -11728,7 +11728,7 @@
                 <a:solidFill>
                   <a:srgbClr val="151D2E"/>
                 </a:solidFill>
-                <a:latin typeface="Inter"/>
+                <a:latin typeface="Arial"/>
               </a:defRPr>
             </a:pPr>
             <a:r>
@@ -11817,7 +11817,7 @@
                 <a:solidFill>
                   <a:srgbClr val="64748B"/>
                 </a:solidFill>
-                <a:latin typeface="Inter"/>
+                <a:latin typeface="Arial"/>
               </a:defRPr>
             </a:pPr>
             <a:r>
@@ -11947,7 +11947,7 @@
                 <a:solidFill>
                   <a:srgbClr val="94A3B8"/>
                 </a:solidFill>
-                <a:latin typeface="Inter"/>
+                <a:latin typeface="Arial"/>
               </a:defRPr>
             </a:pPr>
             <a:r>
@@ -11989,7 +11989,7 @@
                 <a:solidFill>
                   <a:srgbClr val="151D2E"/>
                 </a:solidFill>
-                <a:latin typeface="Inter"/>
+                <a:latin typeface="Arial"/>
               </a:defRPr>
             </a:pPr>
             <a:r>
@@ -12078,7 +12078,7 @@
                 <a:solidFill>
                   <a:srgbClr val="64748B"/>
                 </a:solidFill>
-                <a:latin typeface="Inter"/>
+                <a:latin typeface="Arial"/>
               </a:defRPr>
             </a:pPr>
             <a:r>
@@ -12208,7 +12208,7 @@
                 <a:solidFill>
                   <a:srgbClr val="94A3B8"/>
                 </a:solidFill>
-                <a:latin typeface="Inter"/>
+                <a:latin typeface="Arial"/>
               </a:defRPr>
             </a:pPr>
             <a:r>
@@ -12250,7 +12250,7 @@
                 <a:solidFill>
                   <a:srgbClr val="151D2E"/>
                 </a:solidFill>
-                <a:latin typeface="Inter"/>
+                <a:latin typeface="Arial"/>
               </a:defRPr>
             </a:pPr>
             <a:r>
@@ -12339,7 +12339,7 @@
                 <a:solidFill>
                   <a:srgbClr val="64748B"/>
                 </a:solidFill>
-                <a:latin typeface="Inter"/>
+                <a:latin typeface="Arial"/>
               </a:defRPr>
             </a:pPr>
             <a:r>
@@ -12381,7 +12381,7 @@
                 <a:solidFill>
                   <a:srgbClr val="0096F0"/>
                 </a:solidFill>
-                <a:latin typeface="Inter"/>
+                <a:latin typeface="Arial"/>
               </a:defRPr>
             </a:pPr>
             <a:r>
@@ -12492,7 +12492,7 @@
                 <a:solidFill>
                   <a:srgbClr val="0096F0"/>
                 </a:solidFill>
-                <a:latin typeface="Inter"/>
+                <a:latin typeface="Arial"/>
               </a:defRPr>
             </a:pPr>
             <a:r>
@@ -12534,7 +12534,7 @@
                 <a:solidFill>
                   <a:srgbClr val="FFFFFF"/>
                 </a:solidFill>
-                <a:latin typeface="Inter"/>
+                <a:latin typeface="Arial"/>
               </a:defRPr>
             </a:pPr>
             <a:r>
@@ -12688,7 +12688,7 @@
                 <a:solidFill>
                   <a:srgbClr val="FFFFFF"/>
                 </a:solidFill>
-                <a:latin typeface="Inter"/>
+                <a:latin typeface="Arial"/>
               </a:defRPr>
             </a:pPr>
             <a:r>
@@ -12773,7 +12773,7 @@
                 <a:solidFill>
                   <a:srgbClr val="94A3B8"/>
                 </a:solidFill>
-                <a:latin typeface="Inter"/>
+                <a:latin typeface="Arial"/>
               </a:defRPr>
             </a:pPr>
             <a:r>
@@ -12939,7 +12939,7 @@
                 <a:solidFill>
                   <a:srgbClr val="FFFFFF"/>
                 </a:solidFill>
-                <a:latin typeface="Inter"/>
+                <a:latin typeface="Arial"/>
               </a:defRPr>
             </a:pPr>
             <a:r>
@@ -13024,7 +13024,7 @@
                 <a:solidFill>
                   <a:srgbClr val="94A3B8"/>
                 </a:solidFill>
-                <a:latin typeface="Inter"/>
+                <a:latin typeface="Arial"/>
               </a:defRPr>
             </a:pPr>
             <a:r>
@@ -13190,7 +13190,7 @@
                 <a:solidFill>
                   <a:srgbClr val="FFFFFF"/>
                 </a:solidFill>
-                <a:latin typeface="Inter"/>
+                <a:latin typeface="Arial"/>
               </a:defRPr>
             </a:pPr>
             <a:r>
@@ -13275,7 +13275,7 @@
                 <a:solidFill>
                   <a:srgbClr val="94A3B8"/>
                 </a:solidFill>
-                <a:latin typeface="Inter"/>
+                <a:latin typeface="Arial"/>
               </a:defRPr>
             </a:pPr>
             <a:r>
@@ -13329,7 +13329,7 @@
                 <a:solidFill>
                   <a:srgbClr val="0096F0"/>
                 </a:solidFill>
-                <a:latin typeface="Inter"/>
+                <a:latin typeface="Arial"/>
               </a:defRPr>
             </a:pPr>
             <a:r>
@@ -13371,7 +13371,7 @@
                 <a:solidFill>
                   <a:srgbClr val="64748B"/>
                 </a:solidFill>
-                <a:latin typeface="Inter"/>
+                <a:latin typeface="Arial"/>
               </a:defRPr>
             </a:pPr>
             <a:r>
@@ -13413,7 +13413,7 @@
                 <a:solidFill>
                   <a:srgbClr val="0096F0"/>
                 </a:solidFill>
-                <a:latin typeface="Inter"/>
+                <a:latin typeface="Arial"/>
               </a:defRPr>
             </a:pPr>
             <a:r>
@@ -13455,7 +13455,7 @@
                 <a:solidFill>
                   <a:srgbClr val="64748B"/>
                 </a:solidFill>
-                <a:latin typeface="Inter"/>
+                <a:latin typeface="Arial"/>
               </a:defRPr>
             </a:pPr>
             <a:r>
@@ -13497,7 +13497,7 @@
                 <a:solidFill>
                   <a:srgbClr val="0096F0"/>
                 </a:solidFill>
-                <a:latin typeface="Inter"/>
+                <a:latin typeface="Arial"/>
               </a:defRPr>
             </a:pPr>
             <a:r>
@@ -13539,7 +13539,7 @@
                 <a:solidFill>
                   <a:srgbClr val="64748B"/>
                 </a:solidFill>
-                <a:latin typeface="Inter"/>
+                <a:latin typeface="Arial"/>
               </a:defRPr>
             </a:pPr>
             <a:r>
@@ -13581,7 +13581,7 @@
                 <a:solidFill>
                   <a:srgbClr val="0096F0"/>
                 </a:solidFill>
-                <a:latin typeface="Inter"/>
+                <a:latin typeface="Arial"/>
               </a:defRPr>
             </a:pPr>
             <a:r>
@@ -13623,7 +13623,7 @@
                 <a:solidFill>
                   <a:srgbClr val="64748B"/>
                 </a:solidFill>
-                <a:latin typeface="Inter"/>
+                <a:latin typeface="Arial"/>
               </a:defRPr>
             </a:pPr>
             <a:r>
@@ -13665,7 +13665,7 @@
                 <a:solidFill>
                   <a:srgbClr val="0096F0"/>
                 </a:solidFill>
-                <a:latin typeface="Inter"/>
+                <a:latin typeface="Arial"/>
               </a:defRPr>
             </a:pPr>
             <a:r>
@@ -13707,7 +13707,7 @@
                 <a:solidFill>
                   <a:srgbClr val="64748B"/>
                 </a:solidFill>
-                <a:latin typeface="Inter"/>
+                <a:latin typeface="Arial"/>
               </a:defRPr>
             </a:pPr>
             <a:r>
@@ -13749,7 +13749,7 @@
                 <a:solidFill>
                   <a:srgbClr val="0096F0"/>
                 </a:solidFill>
-                <a:latin typeface="Inter"/>
+                <a:latin typeface="Arial"/>
               </a:defRPr>
             </a:pPr>
             <a:r>
@@ -13791,7 +13791,7 @@
                 <a:solidFill>
                   <a:srgbClr val="64748B"/>
                 </a:solidFill>
-                <a:latin typeface="Inter"/>
+                <a:latin typeface="Arial"/>
               </a:defRPr>
             </a:pPr>
             <a:r>
@@ -13833,7 +13833,7 @@
                 <a:solidFill>
                   <a:srgbClr val="7DD3FC"/>
                 </a:solidFill>
-                <a:latin typeface="Inter"/>
+                <a:latin typeface="Arial"/>
               </a:defRPr>
             </a:pPr>
             <a:r>
@@ -13936,7 +13936,7 @@
                 <a:solidFill>
                   <a:srgbClr val="64748B"/>
                 </a:solidFill>
-                <a:latin typeface="Inter"/>
+                <a:latin typeface="Arial"/>
               </a:defRPr>
             </a:pPr>
             <a:r>
@@ -13978,7 +13978,7 @@
                 <a:solidFill>
                   <a:srgbClr val="151D2E"/>
                 </a:solidFill>
-                <a:latin typeface="Inter"/>
+                <a:latin typeface="Arial"/>
               </a:defRPr>
             </a:pPr>
             <a:r>
@@ -14151,7 +14151,7 @@
                 <a:solidFill>
                   <a:srgbClr val="94A3B8"/>
                 </a:solidFill>
-                <a:latin typeface="Inter"/>
+                <a:latin typeface="Arial"/>
               </a:defRPr>
             </a:pPr>
             <a:r>
@@ -14193,7 +14193,7 @@
                 <a:solidFill>
                   <a:srgbClr val="0096F0"/>
                 </a:solidFill>
-                <a:latin typeface="Inter"/>
+                <a:latin typeface="Arial"/>
               </a:defRPr>
             </a:pPr>
             <a:r>
@@ -14278,7 +14278,7 @@
                 <a:solidFill>
                   <a:srgbClr val="151D2E"/>
                 </a:solidFill>
-                <a:latin typeface="Inter"/>
+                <a:latin typeface="Arial"/>
               </a:defRPr>
             </a:pPr>
             <a:r>
@@ -14320,7 +14320,7 @@
                 <a:solidFill>
                   <a:srgbClr val="64748B"/>
                 </a:solidFill>
-                <a:latin typeface="Inter"/>
+                <a:latin typeface="Arial"/>
               </a:defRPr>
             </a:pPr>
             <a:r>
@@ -14467,7 +14467,7 @@
                 <a:solidFill>
                   <a:srgbClr val="94A3B8"/>
                 </a:solidFill>
-                <a:latin typeface="Inter"/>
+                <a:latin typeface="Arial"/>
               </a:defRPr>
             </a:pPr>
             <a:r>
@@ -14509,7 +14509,7 @@
                 <a:solidFill>
                   <a:srgbClr val="0096F0"/>
                 </a:solidFill>
-                <a:latin typeface="Inter"/>
+                <a:latin typeface="Arial"/>
               </a:defRPr>
             </a:pPr>
             <a:r>
@@ -14594,7 +14594,7 @@
                 <a:solidFill>
                   <a:srgbClr val="151D2E"/>
                 </a:solidFill>
-                <a:latin typeface="Inter"/>
+                <a:latin typeface="Arial"/>
               </a:defRPr>
             </a:pPr>
             <a:r>
@@ -14636,7 +14636,7 @@
                 <a:solidFill>
                   <a:srgbClr val="64748B"/>
                 </a:solidFill>
-                <a:latin typeface="Inter"/>
+                <a:latin typeface="Arial"/>
               </a:defRPr>
             </a:pPr>
             <a:r>
@@ -14778,7 +14778,7 @@
                 <a:solidFill>
                   <a:srgbClr val="94A3B8"/>
                 </a:solidFill>
-                <a:latin typeface="Inter"/>
+                <a:latin typeface="Arial"/>
               </a:defRPr>
             </a:pPr>
             <a:r>
@@ -14820,7 +14820,7 @@
                 <a:solidFill>
                   <a:srgbClr val="0096F0"/>
                 </a:solidFill>
-                <a:latin typeface="Inter"/>
+                <a:latin typeface="Arial"/>
               </a:defRPr>
             </a:pPr>
             <a:r>
@@ -14905,7 +14905,7 @@
                 <a:solidFill>
                   <a:srgbClr val="151D2E"/>
                 </a:solidFill>
-                <a:latin typeface="Inter"/>
+                <a:latin typeface="Arial"/>
               </a:defRPr>
             </a:pPr>
             <a:r>
@@ -14947,7 +14947,7 @@
                 <a:solidFill>
                   <a:srgbClr val="64748B"/>
                 </a:solidFill>
-                <a:latin typeface="Inter"/>
+                <a:latin typeface="Arial"/>
               </a:defRPr>
             </a:pPr>
             <a:r>
@@ -15048,7 +15048,7 @@
                 <a:solidFill>
                   <a:srgbClr val="0096F0"/>
                 </a:solidFill>
-                <a:latin typeface="Inter"/>
+                <a:latin typeface="Arial"/>
               </a:defRPr>
             </a:pPr>
             <a:r>
@@ -15090,7 +15090,7 @@
                 <a:solidFill>
                   <a:srgbClr val="64748B"/>
                 </a:solidFill>
-                <a:latin typeface="Inter"/>
+                <a:latin typeface="Arial"/>
               </a:defRPr>
             </a:pPr>
             <a:r>
@@ -15201,7 +15201,7 @@
                 <a:solidFill>
                   <a:srgbClr val="0096F0"/>
                 </a:solidFill>
-                <a:latin typeface="Inter"/>
+                <a:latin typeface="Arial"/>
               </a:defRPr>
             </a:pPr>
             <a:r>
@@ -15243,7 +15243,7 @@
                 <a:solidFill>
                   <a:srgbClr val="FFFFFF"/>
                 </a:solidFill>
-                <a:latin typeface="Inter"/>
+                <a:latin typeface="Arial"/>
               </a:defRPr>
             </a:pPr>
             <a:r>
@@ -15285,7 +15285,7 @@
                 <a:solidFill>
                   <a:srgbClr val="94A3B8"/>
                 </a:solidFill>
-                <a:latin typeface="Inter"/>
+                <a:latin typeface="Arial"/>
               </a:defRPr>
             </a:pPr>
             <a:r>
@@ -15415,7 +15415,7 @@
                 <a:solidFill>
                   <a:srgbClr val="0096F0"/>
                 </a:solidFill>
-                <a:latin typeface="Inter"/>
+                <a:latin typeface="Arial"/>
               </a:defRPr>
             </a:pPr>
             <a:r>
@@ -15457,7 +15457,7 @@
                 <a:solidFill>
                   <a:srgbClr val="FFFFFF"/>
                 </a:solidFill>
-                <a:latin typeface="Inter"/>
+                <a:latin typeface="Arial"/>
               </a:defRPr>
             </a:pPr>
             <a:r>
@@ -15499,7 +15499,7 @@
                 <a:solidFill>
                   <a:srgbClr val="94A3B8"/>
                 </a:solidFill>
-                <a:latin typeface="Inter"/>
+                <a:latin typeface="Arial"/>
               </a:defRPr>
             </a:pPr>
             <a:r>
@@ -15641,7 +15641,7 @@
                 <a:solidFill>
                   <a:srgbClr val="0096F0"/>
                 </a:solidFill>
-                <a:latin typeface="Inter"/>
+                <a:latin typeface="Arial"/>
               </a:defRPr>
             </a:pPr>
             <a:r>
@@ -15683,7 +15683,7 @@
                 <a:solidFill>
                   <a:srgbClr val="FFFFFF"/>
                 </a:solidFill>
-                <a:latin typeface="Inter"/>
+                <a:latin typeface="Arial"/>
               </a:defRPr>
             </a:pPr>
             <a:r>
@@ -15725,7 +15725,7 @@
                 <a:solidFill>
                   <a:srgbClr val="94A3B8"/>
                 </a:solidFill>
-                <a:latin typeface="Inter"/>
+                <a:latin typeface="Arial"/>
               </a:defRPr>
             </a:pPr>
             <a:r>
@@ -15867,7 +15867,7 @@
                 <a:solidFill>
                   <a:srgbClr val="0096F0"/>
                 </a:solidFill>
-                <a:latin typeface="Inter"/>
+                <a:latin typeface="Arial"/>
               </a:defRPr>
             </a:pPr>
             <a:r>
@@ -15909,7 +15909,7 @@
                 <a:solidFill>
                   <a:srgbClr val="FFFFFF"/>
                 </a:solidFill>
-                <a:latin typeface="Inter"/>
+                <a:latin typeface="Arial"/>
               </a:defRPr>
             </a:pPr>
             <a:r>
@@ -15951,7 +15951,7 @@
                 <a:solidFill>
                   <a:srgbClr val="94A3B8"/>
                 </a:solidFill>
-                <a:latin typeface="Inter"/>
+                <a:latin typeface="Arial"/>
               </a:defRPr>
             </a:pPr>
             <a:r>
@@ -16093,7 +16093,7 @@
                 <a:solidFill>
                   <a:srgbClr val="7DD3FC"/>
                 </a:solidFill>
-                <a:latin typeface="Inter"/>
+                <a:latin typeface="Arial"/>
               </a:defRPr>
             </a:pPr>
             <a:r>
@@ -16135,7 +16135,7 @@
                 <a:solidFill>
                   <a:srgbClr val="FFFFFF"/>
                 </a:solidFill>
-                <a:latin typeface="Inter"/>
+                <a:latin typeface="Arial"/>
               </a:defRPr>
             </a:pPr>
             <a:r>
@@ -16177,7 +16177,7 @@
                 <a:solidFill>
                   <a:srgbClr val="94A3B8"/>
                 </a:solidFill>
-                <a:latin typeface="Inter"/>
+                <a:latin typeface="Arial"/>
               </a:defRPr>
             </a:pPr>
             <a:r>
@@ -16292,7 +16292,7 @@
                 <a:solidFill>
                   <a:srgbClr val="64748B"/>
                 </a:solidFill>
-                <a:latin typeface="Inter"/>
+                <a:latin typeface="Arial"/>
               </a:defRPr>
             </a:pPr>
             <a:r>
@@ -16334,7 +16334,7 @@
                 <a:solidFill>
                   <a:srgbClr val="151D2E"/>
                 </a:solidFill>
-                <a:latin typeface="Inter"/>
+                <a:latin typeface="Arial"/>
               </a:defRPr>
             </a:pPr>
             <a:r>
@@ -17554,7 +17554,7 @@
                 <a:solidFill>
                   <a:srgbClr val="151D2E"/>
                 </a:solidFill>
-                <a:latin typeface="Inter"/>
+                <a:latin typeface="Arial"/>
               </a:defRPr>
             </a:pPr>
             <a:r>
@@ -17665,7 +17665,7 @@
                 <a:solidFill>
                   <a:srgbClr val="0096F0"/>
                 </a:solidFill>
-                <a:latin typeface="Inter"/>
+                <a:latin typeface="Arial"/>
               </a:defRPr>
             </a:pPr>
             <a:r>
@@ -17707,7 +17707,7 @@
                 <a:solidFill>
                   <a:srgbClr val="FFFFFF"/>
                 </a:solidFill>
-                <a:latin typeface="Inter"/>
+                <a:latin typeface="Arial"/>
               </a:defRPr>
             </a:pPr>
             <a:r>
@@ -18604,7 +18604,7 @@
                 <a:solidFill>
                   <a:srgbClr val="94A3B8"/>
                 </a:solidFill>
-                <a:latin typeface="Inter"/>
+                <a:latin typeface="Arial"/>
               </a:defRPr>
             </a:pPr>
             <a:r>
@@ -18646,7 +18646,7 @@
                 <a:solidFill>
                   <a:srgbClr val="94A3B8"/>
                 </a:solidFill>
-                <a:latin typeface="Inter"/>
+                <a:latin typeface="Arial"/>
               </a:defRPr>
             </a:pPr>
             <a:r>
@@ -18688,7 +18688,7 @@
                 <a:solidFill>
                   <a:srgbClr val="94A3B8"/>
                 </a:solidFill>
-                <a:latin typeface="Inter"/>
+                <a:latin typeface="Arial"/>
               </a:defRPr>
             </a:pPr>
             <a:r>
@@ -18730,7 +18730,7 @@
                 <a:solidFill>
                   <a:srgbClr val="94A3B8"/>
                 </a:solidFill>
-                <a:latin typeface="Inter"/>
+                <a:latin typeface="Arial"/>
               </a:defRPr>
             </a:pPr>
             <a:r>
@@ -18772,7 +18772,7 @@
                 <a:solidFill>
                   <a:srgbClr val="94A3B8"/>
                 </a:solidFill>
-                <a:latin typeface="Inter"/>
+                <a:latin typeface="Arial"/>
               </a:defRPr>
             </a:pPr>
             <a:r>

</xml_diff>